<commit_message>
Finalize online course content and synchronize narration artifacts
</commit_message>
<xml_diff>
--- a/산출물/교재/PPTX/실전반_온라인/실전반_07일차.pptx
+++ b/산출물/교재/PPTX/실전반_온라인/실전반_07일차.pptx
@@ -2732,7 +2732,7 @@
           <a:lstStyle/>
           <a:p>
             <a:r>
-              <a:t>이번 시간에는 이번 회차를 정리합니다. 세 업무의 처리 건을 시작 이벤트에서 종료 기록까지 되짚고, 온톨로지와 에이전트, 프로세스가 어떻게 이어지는지 확인한 다음, 복습과 퀴즈로 마무리할게요. 앞의 실습은 정기 점검과 재고 보충 프로세스를 직접 그리고 실행해 보는 과정이었습니다. 아직 결과가 다 나오지 않았더라도, 어디까지 진행됐는지 기록을 놓고 비교해 보겠습니다. 긴급 대응의 처리 건은 쿨러 사건으로 이미 끝까지 따라왔고요. 여기서는 강사가 확인한 기록과 비교할 수 있도록 미리 끝까지 보내 둔 처리 건 셋을 나란히 놓고 봅니다. 화면의 번호나 시각이 실습의 처리 건과 다른 건 그래서예요. 이 세 건을 되짚는 게 네 번째 단원, 세 처리 건이 지나는 다섯 자리입니다. 업무가 서로 다른 이 세 처리 건은 시작 이벤트에서 종료 기록까지 무엇을 거쳤을까요? 그 사이에 무엇이 누구에게 건너갔을까요? AI와 사람이 함께 수행한 업무 흐름을 이 세 건으로 정리해 보겠습니다.</a:t>
+              <a:t>이번 시간에는 이번 회차를 정리합니다. 세 업무의 처리 건을 시작 이벤트에서 종료 기록까지 되짚고, 온톨로지와 에이전트, 프로세스가 어떻게 이어지는지 확인한 다음, 복습과 퀴즈로 마무리할게요. 앞의 실습은 정기 점검과 재고 보충 프로세스를 직접 그리고 실행해 보는 과정이었습니다. 아직 결과가 다 나오지 않았더라도, 어디까지 진행됐는지 기록을 놓고 비교해 보겠습니다. 긴급 대응의 처리 건은 쿨러 사건으로 이미 끝까지 따라왔고요. 여기서는 실습에서 확인한 기록과 비교할 수 있도록 미리 끝까지 보내 둔 처리 건 셋을 나란히 놓고 봅니다. 화면의 번호나 시각이 실습의 처리 건과 다른 건 그래서예요. 이 세 건을 되짚는 게 네 번째 단원, 세 처리 건이 지나는 다섯 자리입니다. 업무가 서로 다른 이 세 처리 건은 시작 이벤트에서 종료 기록까지 무엇을 거쳤을까요? 그 사이에 무엇이 누구에게 건너갔을까요? AI와 사람이 함께 수행한 업무 흐름을 이 세 건으로 정리해 보겠습니다.</a:t>
             </a:r>
           </a:p>
         </p:txBody>
@@ -3992,7 +3992,7 @@
           <a:lstStyle/>
           <a:p>
             <a:r>
-              <a:t>사람의 셋째 일, 프로세스를 고치는 일이 어떻게 돌아가는지 보겠습니다. 프로세스는 한 번 설계하고 끝나는 게 아니에요. 실행이 남긴 기록이 다음 설계로 돌아옵니다. 화면의 네 칸을 따라가 볼게요. 경보가 처리 건을 열고 끝 이벤트에 닿으면, 단계의 시각과 승인, 결과 보고가 기록으로 남죠. 그 기록에서 오래 걸린 단계를 찾고, 여러 건을 모아 사이클 타임과 대기 시간, 거절률로 요약합니다. 승인 응답이 오래 걸리거나 거절이 많으면, 먼저 이유를 조사합니다. 정보가 부족한지, 담당자가 없는지, 승인 기준에 문제가 있는지에 따라 바꿀 곳이 달라지죠. 확인한 원인에 맞춰 정의나 운영 방식을 고칩니다. 고친 정의는 새 판본으로 배포하고, 다음 경보부터 그 판본으로 처리 건이 열립니다. 예를 하나 들어 볼게요. 승인 대기가 자주 길어져서 지연 알림 기한을 바꾸기로 했다고 해 보죠. 업무마다 처음부터 따로 그렸다면 그림마다 다른 자리를 찾아 고쳐야 한다고 했었죠. 이 수업의 세 흐름은 승인 블록과 그 기한을 한 곳에 두고, 세 정의를 거기서 만들어 냅니다. 그래서 기한은 그 한 자리에서 고치고, 세 정의를 다시 생성하고 검증한 다음 새 판본으로 배포합니다. 복사해 둔 그림까지 자동으로 바뀌는 것은 아닙니다. 강사가 화면에서 직접 연결한 흐름이라면 세 흐름에 같은 값을 넣어 주는 것이고요. 그런데 기억해 둘 게 있어요. 고친 정의를 새 판본으로 배포해도, 이미 열려 있던 처리 건은 열릴 때의 판본으로 끝까지 갑니다. 바뀐 기한은 다음 경보부터 적용돼요. 수정한 뒤에는 정상 처리뿐 아니라 거절과 지연 경로도 다시 확인합니다. 승인 기한을 줄였더니 불필요한 알림만 많아지지는 않았는지, 같은 기준의 기록으로 비교해야겠죠. BPM의 분석, 설계, 실행, 모니터링, 개선이 이렇게 한 바퀴를 도는 겁니다. 실행이 남긴 기록이 다시 다음 설계의 출발점이 되는 거죠.</a:t>
+              <a:t>사람의 셋째 일, 프로세스를 고치는 일이 어떻게 돌아가는지 보겠습니다. 프로세스는 한 번 설계하고 끝나는 게 아니에요. 실행이 남긴 기록이 다음 설계로 돌아옵니다. 화면의 네 칸을 따라가 볼게요. 경보가 처리 건을 열고 끝 이벤트에 닿으면, 단계의 시각과 승인, 결과 보고가 기록으로 남죠. 그 기록에서 오래 걸린 단계를 찾고, 여러 건을 모아 사이클 타임과 대기 시간, 거절률로 요약합니다. 승인 응답이 오래 걸리거나 거절이 많으면, 먼저 이유를 조사합니다. 정보가 부족한지, 담당자가 없는지, 승인 기준에 문제가 있는지에 따라 바꿀 곳이 달라지죠. 확인한 원인에 맞춰 정의나 운영 방식을 고칩니다. 고친 정의는 새 판본으로 배포하고, 다음 경보부터 그 판본으로 처리 건이 열립니다. 예를 하나 들어 볼게요. 승인 대기가 자주 길어져서 지연 알림 기한을 바꾸기로 했다고 해 보죠. 업무마다 처음부터 따로 그렸다면 그림마다 다른 자리를 찾아 고쳐야 한다고 했었죠. 이 수업의 세 흐름은 승인 블록과 그 기한을 한 곳에 두고, 세 정의를 거기서 만들어 냅니다. 그래서 기한은 그 한 자리에서 고치고, 세 정의를 다시 생성하고 검증한 다음 새 판본으로 배포합니다. 복사해 둔 그림까지 자동으로 바뀌는 것은 아닙니다. 제가 화면에서 직접 연결한 흐름이라면 세 흐름에 같은 값을 넣어 주는 것이고요. 그런데 기억해 둘 게 있어요. 고친 정의를 새 판본으로 배포해도, 이미 열려 있던 처리 건은 열릴 때의 판본으로 끝까지 갑니다. 바뀐 기한은 다음 경보부터 적용돼요. 수정한 뒤에는 정상 처리뿐 아니라 거절과 지연 경로도 다시 확인합니다. 승인 기한을 줄였더니 불필요한 알림만 많아지지는 않았는지, 같은 기준의 기록으로 비교해야겠죠. BPM의 분석, 설계, 실행, 모니터링, 개선이 이렇게 한 바퀴를 도는 겁니다. 실행이 남긴 기록이 다시 다음 설계의 출발점이 되는 거죠.</a:t>
             </a:r>
           </a:p>
         </p:txBody>
@@ -4552,7 +4552,7 @@
           <a:lstStyle/>
           <a:p>
             <a:r>
-              <a:t>고른 답을 정답과 하나씩 맞춰 볼게요. 첫 문제의 정답은 2번입니다. 거절 종결에 닿았다는 건, 발주로 가는 선을 지나지 않았다는 뜻이에요. 문제에서 다른 재고 변화는 없다고 했으므로, 처리 건은 닫혔지만 재고 부족은 그대로 남아 있죠. 1번은 처리 건이 닫힌 것과 업무가 해결된 것을 헷갈렸고요, 3번은 거절 경로에서는 발주 자체가 없다는 걸 놓쳤습니다. 4번의 타이머는 알림만 보낼 뿐, 처리 건을 닫지 않아요. 두 번째 문제의 정답은 4번이에요. 단계마다 남은 시작과 끝의 시각이 어디를 더 조사할지 알려 줍니다. 반복되는 지연과 대기 이유, 아직 끝나지 않은 건까지 확인해야 병목을 판단할 수 있어요. 1번과 2번은 처리 건이 어떻게 끝났는지를 알려 주는 기록이지, 시간을 알려 주지는 않죠. 3번은 그림의 표식이라서 처리 건마다 달라지는 시간을 담고 있지 않습니다. 세 번째 문제의 정답은 3번입니다. 이 수업에서 유지하기로 한 정책은 에이전트가 제안하고, 책임질 역할이 승인한 뒤에 업무를 실행하는 것입니다. 1번과 2번은 사람의 결정을 아예 없애는 설계예요. 4번은 사람이 결정하지 않았는데 기한이 지났다고 효과가 나가는 설계고요. 이런 흐름은 등록하기 전 검사에서도 받아 주지 않습니다. 여기까지가 이번 회차입니다. 다음 회차는 과정의 마지막 회차예요. 지금까지 쌓은 지식과 에이전트, 프로세스를 되짚고, 강사가 정한 작은 업무 주제에 적용해서 지식 구조와 에이전트, 업무 흐름을 직접 만들어 보겠습니다. 이번 회차도 수고 많으셨습니다. 감사합니다.</a:t>
+              <a:t>고른 답을 정답과 하나씩 맞춰 볼게요. 첫 문제의 정답은 2번입니다. 거절 종결에 닿았다는 건, 발주로 가는 선을 지나지 않았다는 뜻이에요. 문제에서 다른 재고 변화는 없다고 했으므로, 처리 건은 닫혔지만 재고 부족은 그대로 남아 있죠. 1번은 처리 건이 닫힌 것과 업무가 해결된 것을 헷갈렸고요, 3번은 거절 경로에서는 발주 자체가 없다는 걸 놓쳤습니다. 4번의 타이머는 알림만 보낼 뿐, 처리 건을 닫지 않아요. 두 번째 문제의 정답은 4번이에요. 단계마다 남은 시작과 끝의 시각이 어디를 더 조사할지 알려 줍니다. 반복되는 지연과 대기 이유, 아직 끝나지 않은 건까지 확인해야 병목을 판단할 수 있어요. 1번과 2번은 처리 건이 어떻게 끝났는지를 알려 주는 기록이지, 시간을 알려 주지는 않죠. 3번은 그림의 표식이라서 처리 건마다 달라지는 시간을 담고 있지 않습니다. 세 번째 문제의 정답은 3번입니다. 이 수업에서 유지하기로 한 정책은 에이전트가 제안하고, 책임질 역할이 승인한 뒤에 업무를 실행하는 것입니다. 1번과 2번은 사람의 결정을 아예 없애는 설계예요. 4번은 사람이 결정하지 않았는데 기한이 지났다고 효과가 나가는 설계고요. 이런 흐름은 등록하기 전 검사에서도 받아 주지 않습니다. 여기까지가 이번 회차입니다. 다음 회차는 과정의 마지막 회차예요. 지금까지 쌓은 지식과 에이전트, 프로세스를 되짚고, 생산·정비 조율 업무에 적용해서 지식 구조와 에이전트, 업무 흐름을 직접 만들어 보겠습니다. 이번 회차도 수고 많으셨습니다. 감사합니다.</a:t>
             </a:r>
           </a:p>
         </p:txBody>

</xml_diff>